<commit_message>
docs(pitch-decks): update Sequoia deck and email with David Cahn Dec 2025 enterprise fatigue quote
- Slide 2 (Why Sequoia): Added David Cahn pullquote from 'AI in 2026: A Tale of Two AIs'
  ('big enterprises are struggling to implement AI in-house... fatigue and disappointment')
- Thesis alignment reframed around solving enterprise AI adoption fatigue
- Portfolio adjacency updated to include Vanta (compliance automation) alongside Snowflake/Scale AI
- Key Angle updated: 'Solving enterprise AI adoption fatigue with purpose-built governance infrastructure'
- CTA tagline updated to match new angle
- Updated investors-001-025.cjs with new whyAlign/hookSlide/keyAngle
- Regenerated INVESTOR-EMAILS.md (483 emails) and all 120 PPTX decks
</commit_message>
<xml_diff>
--- a/docs/pitch-decks/investor-100/pptx/002-sequoia.pptx
+++ b/docs/pitch-decks/investor-100/pptx/002-sequoia.pptx
@@ -2215,7 +2215,7 @@
                   <a:srgbClr val="8B8FA3"/>
                 </a:solidFill>
               </a:rPr>
-              <a:t>Personalized for Sequoia Capital — Category-defining AI governance infrastructure</a:t>
+              <a:t>Personalized for Sequoia Capital — Solving enterprise AI adoption fatigue with purpose-built governance infrastructure</a:t>
             </a:r>
             <a:endParaRPr lang="en-US" sz="1400" dirty="0"/>
           </a:p>
@@ -2867,7 +2867,7 @@
                   <a:srgbClr val="8B8FA3"/>
                 </a:solidFill>
               </a:rPr>
-              <a:t>Datacendia is creating the AI governance category — no incumbent exists. Like Snowflake did for cloud data, Datacendia defines how enterprises prove AI accountability.</a:t>
+              <a:t>David Cahn wrote in December 2025 that "big enterprises are struggling to implement AI in-house, which is leading to fatigue and disappointment" and that "with enterprises facing adoption fatigue on DIY implementations, startups are gaining even more momentum." Datacendia is exactly that startup — purpose-built AI governance infrastructure so enterprises don't have to build it themselves.</a:t>
             </a:r>
             <a:endParaRPr lang="en-US" sz="1100" dirty="0"/>
           </a:p>
@@ -3076,7 +3076,7 @@
                   <a:srgbClr val="8B8FA3"/>
                 </a:solidFill>
               </a:rPr>
-              <a:t>Sequoia invested in Snowflake (data cloud) and Scale AI (data labeling). Datacendia is the next data infrastructure layer: cryptographic proof that AI decisions are accountable.</a:t>
+              <a:t>Sequoia invested in Snowflake (data cloud), Scale AI (data labeling), and Vanta (compliance automation). Datacendia is the next infrastructure layer: cryptographic proof that AI decisions are accountable — solving the enterprise adoption fatigue David identified.</a:t>
             </a:r>
             <a:endParaRPr lang="en-US" sz="1100" dirty="0"/>
           </a:p>
@@ -4212,7 +4212,7 @@
                   <a:srgbClr val="FFFFFF"/>
                 </a:solidFill>
               </a:rPr>
-              <a:t>Category-defining AI governance infrastructure</a:t>
+              <a:t>Solving enterprise AI adoption fatigue with purpose-built governance infrastructure</a:t>
             </a:r>
             <a:endParaRPr lang="en-US" sz="1400" dirty="0"/>
           </a:p>

</xml_diff>